<commit_message>
Add seven avatar reference photos and revise foam and towel designs
</commit_message>
<xml_diff>
--- a/documents/slides/bath-set-production-slides.pptx
+++ b/documents/slides/bath-set-production-slides.pptx
@@ -3340,7 +3340,7 @@
               </a:defRPr>
             </a:pPr>
             <a:r>
-              <a:t>アース製薬 企業ブース｜3Dお風呂セット 制作発注資料｜制作内容 v0.4</a:t>
+              <a:t>アース製薬 企業ブース｜3Dお風呂セット 制作発注資料｜制作内容 v0.5</a:t>
             </a:r>
           </a:p>
         </p:txBody>
@@ -3587,7 +3587,7 @@
         <p:spPr>
           <a:xfrm>
             <a:off x="2258568" y="5056632"/>
-            <a:ext cx="1828800" cy="292608"/>
+            <a:ext cx="2011680" cy="292608"/>
           </a:xfrm>
           <a:prstGeom prst="roundRect">
             <a:avLst>
@@ -3632,7 +3632,7 @@
         <p:spPr>
           <a:xfrm>
             <a:off x="2350008" y="5097780"/>
-            <a:ext cx="1664208" cy="228600"/>
+            <a:ext cx="1847088" cy="228600"/>
           </a:xfrm>
           <a:prstGeom prst="rect">
             <a:avLst/>
@@ -3657,7 +3657,7 @@
               </a:defRPr>
             </a:pPr>
             <a:r>
-              <a:t>対応アバター 5種</a:t>
+              <a:t>女性4種・男性3種</a:t>
             </a:r>
           </a:p>
         </p:txBody>
@@ -3748,7 +3748,7 @@
       </p:sp>
       <p:pic>
         <p:nvPicPr>
-          <p:cNvPr id="17" name="Picture 16" descr="exec-871844d4-edbb-4a08-9d69-90132a8b8d7d.png"/>
+          <p:cNvPr id="17" name="Picture 16" descr="exec-c7a9a72c-5423-4325-bae1-c7d3b8f836c6.png"/>
           <p:cNvPicPr>
             <a:picLocks noChangeAspect="1"/>
           </p:cNvPicPr>
@@ -3756,6 +3756,7 @@
         </p:nvPicPr>
         <p:blipFill>
           <a:blip r:embed="rId2"/>
+          <a:srcRect r="50000" b="50000"/>
           <a:stretch>
             <a:fillRect/>
           </a:stretch>
@@ -3763,16 +3764,91 @@
         <p:spPr>
           <a:xfrm>
             <a:off x="6601968" y="1627632"/>
-            <a:ext cx="4526280" cy="4526280"/>
+            <a:ext cx="2263140" cy="2263140"/>
           </a:xfrm>
           <a:prstGeom prst="rect">
             <a:avLst/>
           </a:prstGeom>
         </p:spPr>
       </p:pic>
-      <p:sp>
-        <p:nvSpPr>
-          <p:cNvPr id="18" name="TextBox 17"/>
+      <p:pic>
+        <p:nvPicPr>
+          <p:cNvPr id="18" name="Picture 17" descr="exec-c7a9a72c-5423-4325-bae1-c7d3b8f836c6.png"/>
+          <p:cNvPicPr>
+            <a:picLocks noChangeAspect="1"/>
+          </p:cNvPicPr>
+          <p:nvPr/>
+        </p:nvPicPr>
+        <p:blipFill>
+          <a:blip r:embed="rId2"/>
+          <a:srcRect l="50000" b="50000"/>
+          <a:stretch>
+            <a:fillRect/>
+          </a:stretch>
+        </p:blipFill>
+        <p:spPr>
+          <a:xfrm>
+            <a:off x="8865108" y="1627632"/>
+            <a:ext cx="2263140" cy="2263140"/>
+          </a:xfrm>
+          <a:prstGeom prst="rect">
+            <a:avLst/>
+          </a:prstGeom>
+        </p:spPr>
+      </p:pic>
+      <p:pic>
+        <p:nvPicPr>
+          <p:cNvPr id="19" name="Picture 18" descr="exec-871844d4-edbb-4a08-9d69-90132a8b8d7d.png"/>
+          <p:cNvPicPr>
+            <a:picLocks noChangeAspect="1"/>
+          </p:cNvPicPr>
+          <p:nvPr/>
+        </p:nvPicPr>
+        <p:blipFill>
+          <a:blip r:embed="rId3"/>
+          <a:srcRect r="50000" t="50000"/>
+          <a:stretch>
+            <a:fillRect/>
+          </a:stretch>
+        </p:blipFill>
+        <p:spPr>
+          <a:xfrm>
+            <a:off x="6601968" y="3890772"/>
+            <a:ext cx="2263140" cy="2263140"/>
+          </a:xfrm>
+          <a:prstGeom prst="rect">
+            <a:avLst/>
+          </a:prstGeom>
+        </p:spPr>
+      </p:pic>
+      <p:pic>
+        <p:nvPicPr>
+          <p:cNvPr id="20" name="Picture 19" descr="exec-871844d4-edbb-4a08-9d69-90132a8b8d7d.png"/>
+          <p:cNvPicPr>
+            <a:picLocks noChangeAspect="1"/>
+          </p:cNvPicPr>
+          <p:nvPr/>
+        </p:nvPicPr>
+        <p:blipFill>
+          <a:blip r:embed="rId3"/>
+          <a:srcRect l="50000" t="50000"/>
+          <a:stretch>
+            <a:fillRect/>
+          </a:stretch>
+        </p:blipFill>
+        <p:spPr>
+          <a:xfrm>
+            <a:off x="8865108" y="3890772"/>
+            <a:ext cx="2263140" cy="2263140"/>
+          </a:xfrm>
+          <a:prstGeom prst="rect">
+            <a:avLst/>
+          </a:prstGeom>
+        </p:spPr>
+      </p:pic>
+      <p:sp>
+        <p:nvSpPr>
+          <p:cNvPr id="21" name="TextBox 20"/>
           <p:cNvSpPr txBox="1"/>
           <p:nvPr/>
         </p:nvSpPr>
@@ -4072,7 +4148,7 @@
               </a:defRPr>
             </a:pPr>
             <a:r>
-              <a:t>アース製薬 企業ブース｜3Dお風呂セット 制作発注資料｜制作内容 v0.4</a:t>
+              <a:t>アース製薬 企業ブース｜3Dお風呂セット 制作発注資料｜制作内容 v0.5</a:t>
             </a:r>
           </a:p>
         </p:txBody>
@@ -4163,7 +4239,7 @@
       </p:sp>
       <p:pic>
         <p:nvPicPr>
-          <p:cNvPr id="10" name="Picture 9" descr="exec-871844d4-edbb-4a08-9d69-90132a8b8d7d.png"/>
+          <p:cNvPr id="10" name="Picture 9" descr="exec-c7a9a72c-5423-4325-bae1-c7d3b8f836c6.png"/>
           <p:cNvPicPr>
             <a:picLocks noChangeAspect="1"/>
           </p:cNvPicPr>
@@ -4350,7 +4426,7 @@
       </p:sp>
       <p:pic>
         <p:nvPicPr>
-          <p:cNvPr id="15" name="Picture 14" descr="exec-871844d4-edbb-4a08-9d69-90132a8b8d7d.png"/>
+          <p:cNvPr id="15" name="Picture 14" descr="exec-c7a9a72c-5423-4325-bae1-c7d3b8f836c6.png"/>
           <p:cNvPicPr>
             <a:picLocks noChangeAspect="1"/>
           </p:cNvPicPr>
@@ -4446,7 +4522,7 @@
               </a:defRPr>
             </a:pPr>
             <a:r>
-              <a:t>もこもこターバン</a:t>
+              <a:t>もこもこ泡ターバン</a:t>
             </a:r>
           </a:p>
         </p:txBody>
@@ -4485,7 +4561,7 @@
               </a:defRPr>
             </a:pPr>
             <a:r>
-              <a:t>頭に巻く、ふわふわのターバン</a:t>
+              <a:t>頭に載せる、白いもこもこの泡</a:t>
             </a:r>
           </a:p>
         </p:txBody>
@@ -4544,7 +4620,7 @@
           <p:nvPr/>
         </p:nvPicPr>
         <p:blipFill>
-          <a:blip r:embed="rId2"/>
+          <a:blip r:embed="rId3"/>
           <a:srcRect r="50000" t="50000"/>
           <a:stretch>
             <a:fillRect/>
@@ -4731,7 +4807,7 @@
           <p:nvPr/>
         </p:nvPicPr>
         <p:blipFill>
-          <a:blip r:embed="rId2"/>
+          <a:blip r:embed="rId3"/>
           <a:srcRect l="50000" t="50000"/>
           <a:stretch>
             <a:fillRect/>
@@ -5084,7 +5160,7 @@
               </a:defRPr>
             </a:pPr>
             <a:r>
-              <a:t>頭部小物｜タオルとターバン</a:t>
+              <a:t>頭部小物｜薄いタオルと、もこもこの泡</a:t>
             </a:r>
           </a:p>
         </p:txBody>
@@ -5123,7 +5199,7 @@
               </a:defRPr>
             </a:pPr>
             <a:r>
-              <a:t>どちらも、頭に装着して使うアイテムです。</a:t>
+              <a:t>タオルは薄く、ターバンは布ではなく泡として制作します。</a:t>
             </a:r>
           </a:p>
         </p:txBody>
@@ -5205,7 +5281,7 @@
               </a:defRPr>
             </a:pPr>
             <a:r>
-              <a:t>アース製薬 企業ブース｜3Dお風呂セット 制作発注資料｜制作内容 v0.4</a:t>
+              <a:t>アース製薬 企業ブース｜3Dお風呂セット 制作発注資料｜制作内容 v0.5</a:t>
             </a:r>
           </a:p>
         </p:txBody>
@@ -5296,7 +5372,7 @@
       </p:sp>
       <p:pic>
         <p:nvPicPr>
-          <p:cNvPr id="10" name="Picture 9" descr="exec-871844d4-edbb-4a08-9d69-90132a8b8d7d.png"/>
+          <p:cNvPr id="10" name="Picture 9" descr="exec-c7a9a72c-5423-4325-bae1-c7d3b8f836c6.png"/>
           <p:cNvPicPr>
             <a:picLocks noChangeAspect="1"/>
           </p:cNvPicPr>
@@ -5392,7 +5468,7 @@
               </a:defRPr>
             </a:pPr>
             <a:r>
-              <a:t>折り畳んだ白いタオルの上に、</a:t>
+              <a:t>薄い白いタオルの上に、</a:t>
             </a:r>
           </a:p>
           <a:p>
@@ -5499,7 +5575,7 @@
       </p:sp>
       <p:pic>
         <p:nvPicPr>
-          <p:cNvPr id="15" name="Picture 14" descr="exec-871844d4-edbb-4a08-9d69-90132a8b8d7d.png"/>
+          <p:cNvPr id="15" name="Picture 14" descr="exec-c7a9a72c-5423-4325-bae1-c7d3b8f836c6.png"/>
           <p:cNvPicPr>
             <a:picLocks noChangeAspect="1"/>
           </p:cNvPicPr>
@@ -5556,7 +5632,7 @@
               </a:defRPr>
             </a:pPr>
             <a:r>
-              <a:t>もこもこターバン</a:t>
+              <a:t>もこもこ泡ターバン</a:t>
             </a:r>
           </a:p>
         </p:txBody>
@@ -5595,7 +5671,7 @@
               </a:defRPr>
             </a:pPr>
             <a:r>
-              <a:t>白く、ふんわりした質感の</a:t>
+              <a:t>白いもこもこの泡に、</a:t>
             </a:r>
           </a:p>
           <a:p>
@@ -5611,7 +5687,23 @@
               </a:defRPr>
             </a:pPr>
             <a:r>
-              <a:t>頭に巻くターバン。</a:t>
+              <a:t>透明なシャボン玉を添える。</a:t>
+            </a:r>
+          </a:p>
+          <a:p>
+            <a:pPr>
+              <a:spcAft>
+                <a:spcPts val="800"/>
+              </a:spcAft>
+              <a:defRPr sz="1700" b="0">
+                <a:solidFill>
+                  <a:srgbClr val="173E3C"/>
+                </a:solidFill>
+                <a:latin typeface="Noto Sans CJK JP"/>
+              </a:defRPr>
+            </a:pPr>
+            <a:r>
+              <a:t>布のターバンではありません。</a:t>
             </a:r>
           </a:p>
         </p:txBody>
@@ -5918,7 +6010,7 @@
               </a:defRPr>
             </a:pPr>
             <a:r>
-              <a:t>アース製薬 企業ブース｜3Dお風呂セット 制作発注資料｜制作内容 v0.4</a:t>
+              <a:t>アース製薬 企業ブース｜3Dお風呂セット 制作発注資料｜制作内容 v0.5</a:t>
             </a:r>
           </a:p>
         </p:txBody>
@@ -6467,7 +6559,7 @@
               </a:defRPr>
             </a:pPr>
             <a:r>
-              <a:t>アース製薬 企業ブース｜3Dお風呂セット 制作発注資料｜制作内容 v0.4</a:t>
+              <a:t>アース製薬 企業ブース｜3Dお風呂セット 制作発注資料｜制作内容 v0.5</a:t>
             </a:r>
           </a:p>
         </p:txBody>
@@ -6855,7 +6947,7 @@
               </a:defRPr>
             </a:pPr>
             <a:r>
-              <a:t>以下の5アバターで着用できるように制作します。</a:t>
+              <a:t>女性4種・男性3種で着用できるように制作します。</a:t>
             </a:r>
           </a:p>
         </p:txBody>
@@ -7002,7 +7094,7 @@
               </a:defRPr>
             </a:pPr>
             <a:r>
-              <a:t>バスタオルの対応アバター｜5種</a:t>
+              <a:t>バスタオルの対応アバター｜女性4種・男性3種</a:t>
             </a:r>
           </a:p>
         </p:txBody>
@@ -7041,7 +7133,7 @@
               </a:defRPr>
             </a:pPr>
             <a:r>
-              <a:t>以下のアバターに合わせたバスタオルを制作します。</a:t>
+              <a:t>以下の7種で着用できるバスタオルを制作します。</a:t>
             </a:r>
           </a:p>
         </p:txBody>
@@ -7123,7 +7215,7 @@
               </a:defRPr>
             </a:pPr>
             <a:r>
-              <a:t>アース製薬 企業ブース｜3Dお風呂セット 制作発注資料｜制作内容 v0.4</a:t>
+              <a:t>アース製薬 企業ブース｜3Dお風呂セット 制作発注資料｜制作内容 v0.5</a:t>
             </a:r>
           </a:p>
         </p:txBody>
@@ -7169,14 +7261,92 @@
       </p:sp>
       <p:sp>
         <p:nvSpPr>
-          <p:cNvPr id="9" name="Rounded Rectangle 8"/>
+          <p:cNvPr id="9" name="TextBox 8"/>
+          <p:cNvSpPr txBox="1"/>
+          <p:nvPr/>
+        </p:nvSpPr>
+        <p:spPr>
+          <a:xfrm>
+            <a:off x="676656" y="1682496"/>
+            <a:ext cx="1828800" cy="274320"/>
+          </a:xfrm>
+          <a:prstGeom prst="rect">
+            <a:avLst/>
+          </a:prstGeom>
+          <a:noFill/>
+        </p:spPr>
+        <p:txBody>
+          <a:bodyPr wrap="square" lIns="0" rIns="0" tIns="0" bIns="0">
+            <a:spAutoFit/>
+          </a:bodyPr>
+          <a:lstStyle/>
+          <a:p>
+            <a:pPr>
+              <a:spcAft>
+                <a:spcPts val="800"/>
+              </a:spcAft>
+              <a:defRPr sz="1500" b="1">
+                <a:solidFill>
+                  <a:srgbClr val="24685E"/>
+                </a:solidFill>
+                <a:latin typeface="Noto Sans CJK JP"/>
+              </a:defRPr>
+            </a:pPr>
+            <a:r>
+              <a:t>女性 4種</a:t>
+            </a:r>
+          </a:p>
+        </p:txBody>
+      </p:sp>
+      <p:sp>
+        <p:nvSpPr>
+          <p:cNvPr id="10" name="TextBox 9"/>
+          <p:cNvSpPr txBox="1"/>
+          <p:nvPr/>
+        </p:nvSpPr>
+        <p:spPr>
+          <a:xfrm>
+            <a:off x="676656" y="4050791"/>
+            <a:ext cx="1828800" cy="274320"/>
+          </a:xfrm>
+          <a:prstGeom prst="rect">
+            <a:avLst/>
+          </a:prstGeom>
+          <a:noFill/>
+        </p:spPr>
+        <p:txBody>
+          <a:bodyPr wrap="square" lIns="0" rIns="0" tIns="0" bIns="0">
+            <a:spAutoFit/>
+          </a:bodyPr>
+          <a:lstStyle/>
+          <a:p>
+            <a:pPr>
+              <a:spcAft>
+                <a:spcPts val="800"/>
+              </a:spcAft>
+              <a:defRPr sz="1500" b="1">
+                <a:solidFill>
+                  <a:srgbClr val="24685E"/>
+                </a:solidFill>
+                <a:latin typeface="Noto Sans CJK JP"/>
+              </a:defRPr>
+            </a:pPr>
+            <a:r>
+              <a:t>男性 3種</a:t>
+            </a:r>
+          </a:p>
+        </p:txBody>
+      </p:sp>
+      <p:sp>
+        <p:nvSpPr>
+          <p:cNvPr id="11" name="Rounded Rectangle 10"/>
           <p:cNvSpPr/>
           <p:nvPr/>
         </p:nvSpPr>
         <p:spPr>
           <a:xfrm>
-            <a:off x="658368" y="1901952"/>
-            <a:ext cx="5532120" cy="658368"/>
+            <a:off x="658368" y="1984248"/>
+            <a:ext cx="2596896" cy="1920240"/>
           </a:xfrm>
           <a:prstGeom prst="roundRect">
             <a:avLst>
@@ -7212,73 +7382,60 @@
           </a:p>
         </p:txBody>
       </p:sp>
-      <p:sp>
-        <p:nvSpPr>
-          <p:cNvPr id="10" name="TextBox 9"/>
-          <p:cNvSpPr txBox="1"/>
-          <p:nvPr/>
-        </p:nvSpPr>
-        <p:spPr>
-          <a:xfrm>
-            <a:off x="896112" y="2048256"/>
-            <a:ext cx="521207" cy="320040"/>
-          </a:xfrm>
-          <a:prstGeom prst="rect">
-            <a:avLst/>
-          </a:prstGeom>
-          <a:noFill/>
-        </p:spPr>
-        <p:txBody>
-          <a:bodyPr wrap="square" lIns="0" rIns="0" tIns="0" bIns="0">
-            <a:spAutoFit/>
-          </a:bodyPr>
-          <a:lstStyle/>
-          <a:p>
-            <a:pPr>
+      <p:pic>
+        <p:nvPicPr>
+          <p:cNvPr id="12" name="Picture 11" descr="shinano.jpg">
+            <a:hlinkClick r:id="rId3"/>
+          </p:cNvPr>
+          <p:cNvPicPr>
+            <a:picLocks noChangeAspect="1"/>
+          </p:cNvPicPr>
+          <p:nvPr/>
+        </p:nvPicPr>
+        <p:blipFill>
+          <a:blip r:embed="rId2"/>
+          <a:stretch>
+            <a:fillRect/>
+          </a:stretch>
+        </p:blipFill>
+        <p:spPr>
+          <a:xfrm>
+            <a:off x="1225295" y="2075688"/>
+            <a:ext cx="1463040" cy="1463040"/>
+          </a:xfrm>
+          <a:prstGeom prst="rect">
+            <a:avLst/>
+          </a:prstGeom>
+        </p:spPr>
+      </p:pic>
+      <p:sp>
+        <p:nvSpPr>
+          <p:cNvPr id="13" name="TextBox 12"/>
+          <p:cNvSpPr txBox="1"/>
+          <p:nvPr/>
+        </p:nvSpPr>
+        <p:spPr>
+          <a:xfrm>
+            <a:off x="813816" y="3602736"/>
+            <a:ext cx="2286000" cy="274320"/>
+          </a:xfrm>
+          <a:prstGeom prst="rect">
+            <a:avLst/>
+          </a:prstGeom>
+          <a:noFill/>
+        </p:spPr>
+        <p:txBody>
+          <a:bodyPr wrap="square" lIns="0" rIns="0" tIns="0" bIns="0">
+            <a:spAutoFit/>
+          </a:bodyPr>
+          <a:lstStyle/>
+          <a:p>
+            <a:pPr algn="ctr">
               <a:spcAft>
                 <a:spcPts val="800"/>
               </a:spcAft>
               <a:defRPr sz="1600" b="1">
                 <a:solidFill>
-                  <a:srgbClr val="24685E"/>
-                </a:solidFill>
-                <a:latin typeface="Noto Sans CJK JP"/>
-              </a:defRPr>
-            </a:pPr>
-            <a:r>
-              <a:t>01</a:t>
-            </a:r>
-          </a:p>
-        </p:txBody>
-      </p:sp>
-      <p:sp>
-        <p:nvSpPr>
-          <p:cNvPr id="11" name="TextBox 10"/>
-          <p:cNvSpPr txBox="1"/>
-          <p:nvPr/>
-        </p:nvSpPr>
-        <p:spPr>
-          <a:xfrm>
-            <a:off x="1691640" y="2011680"/>
-            <a:ext cx="2560320" cy="411480"/>
-          </a:xfrm>
-          <a:prstGeom prst="rect">
-            <a:avLst/>
-          </a:prstGeom>
-          <a:noFill/>
-        </p:spPr>
-        <p:txBody>
-          <a:bodyPr wrap="square" lIns="0" rIns="0" tIns="0" bIns="0">
-            <a:spAutoFit/>
-          </a:bodyPr>
-          <a:lstStyle/>
-          <a:p>
-            <a:pPr>
-              <a:spcAft>
-                <a:spcPts val="800"/>
-              </a:spcAft>
-              <a:defRPr sz="2300" b="1">
-                <a:solidFill>
                   <a:srgbClr val="173E3C"/>
                 </a:solidFill>
                 <a:latin typeface="Noto Sans CJK JP"/>
@@ -7292,53 +7449,14 @@
       </p:sp>
       <p:sp>
         <p:nvSpPr>
-          <p:cNvPr id="12" name="TextBox 11"/>
-          <p:cNvSpPr txBox="1"/>
-          <p:nvPr/>
-        </p:nvSpPr>
-        <p:spPr>
-          <a:xfrm>
-            <a:off x="4352544" y="2084832"/>
-            <a:ext cx="1463040" cy="310896"/>
-          </a:xfrm>
-          <a:prstGeom prst="rect">
-            <a:avLst/>
-          </a:prstGeom>
-          <a:noFill/>
-        </p:spPr>
-        <p:txBody>
-          <a:bodyPr wrap="square" lIns="0" rIns="0" tIns="0" bIns="0">
-            <a:spAutoFit/>
-          </a:bodyPr>
-          <a:lstStyle/>
-          <a:p>
-            <a:pPr>
-              <a:spcAft>
-                <a:spcPts val="800"/>
-              </a:spcAft>
-              <a:defRPr sz="1400" b="0">
-                <a:solidFill>
-                  <a:srgbClr val="61716B"/>
-                </a:solidFill>
-                <a:latin typeface="Noto Sans CJK JP"/>
-              </a:defRPr>
-            </a:pPr>
-            <a:r>
-              <a:t>Shinano</a:t>
-            </a:r>
-          </a:p>
-        </p:txBody>
-      </p:sp>
-      <p:sp>
-        <p:nvSpPr>
-          <p:cNvPr id="13" name="Rounded Rectangle 12"/>
+          <p:cNvPr id="14" name="Rounded Rectangle 13"/>
           <p:cNvSpPr/>
           <p:nvPr/>
         </p:nvSpPr>
         <p:spPr>
           <a:xfrm>
-            <a:off x="658368" y="2688336"/>
-            <a:ext cx="5532120" cy="658368"/>
+            <a:off x="3493008" y="1984248"/>
+            <a:ext cx="2596896" cy="1920240"/>
           </a:xfrm>
           <a:prstGeom prst="roundRect">
             <a:avLst>
@@ -7374,73 +7492,60 @@
           </a:p>
         </p:txBody>
       </p:sp>
-      <p:sp>
-        <p:nvSpPr>
-          <p:cNvPr id="14" name="TextBox 13"/>
-          <p:cNvSpPr txBox="1"/>
-          <p:nvPr/>
-        </p:nvSpPr>
-        <p:spPr>
-          <a:xfrm>
-            <a:off x="896112" y="2834640"/>
-            <a:ext cx="521207" cy="320040"/>
-          </a:xfrm>
-          <a:prstGeom prst="rect">
-            <a:avLst/>
-          </a:prstGeom>
-          <a:noFill/>
-        </p:spPr>
-        <p:txBody>
-          <a:bodyPr wrap="square" lIns="0" rIns="0" tIns="0" bIns="0">
-            <a:spAutoFit/>
-          </a:bodyPr>
-          <a:lstStyle/>
-          <a:p>
-            <a:pPr>
+      <p:pic>
+        <p:nvPicPr>
+          <p:cNvPr id="15" name="Picture 14" descr="manuka.jpg">
+            <a:hlinkClick r:id="rId5"/>
+          </p:cNvPr>
+          <p:cNvPicPr>
+            <a:picLocks noChangeAspect="1"/>
+          </p:cNvPicPr>
+          <p:nvPr/>
+        </p:nvPicPr>
+        <p:blipFill>
+          <a:blip r:embed="rId4"/>
+          <a:stretch>
+            <a:fillRect/>
+          </a:stretch>
+        </p:blipFill>
+        <p:spPr>
+          <a:xfrm>
+            <a:off x="4059936" y="2075688"/>
+            <a:ext cx="1463040" cy="1463040"/>
+          </a:xfrm>
+          <a:prstGeom prst="rect">
+            <a:avLst/>
+          </a:prstGeom>
+        </p:spPr>
+      </p:pic>
+      <p:sp>
+        <p:nvSpPr>
+          <p:cNvPr id="16" name="TextBox 15"/>
+          <p:cNvSpPr txBox="1"/>
+          <p:nvPr/>
+        </p:nvSpPr>
+        <p:spPr>
+          <a:xfrm>
+            <a:off x="3648456" y="3602736"/>
+            <a:ext cx="2286000" cy="274320"/>
+          </a:xfrm>
+          <a:prstGeom prst="rect">
+            <a:avLst/>
+          </a:prstGeom>
+          <a:noFill/>
+        </p:spPr>
+        <p:txBody>
+          <a:bodyPr wrap="square" lIns="0" rIns="0" tIns="0" bIns="0">
+            <a:spAutoFit/>
+          </a:bodyPr>
+          <a:lstStyle/>
+          <a:p>
+            <a:pPr algn="ctr">
               <a:spcAft>
                 <a:spcPts val="800"/>
               </a:spcAft>
               <a:defRPr sz="1600" b="1">
                 <a:solidFill>
-                  <a:srgbClr val="24685E"/>
-                </a:solidFill>
-                <a:latin typeface="Noto Sans CJK JP"/>
-              </a:defRPr>
-            </a:pPr>
-            <a:r>
-              <a:t>02</a:t>
-            </a:r>
-          </a:p>
-        </p:txBody>
-      </p:sp>
-      <p:sp>
-        <p:nvSpPr>
-          <p:cNvPr id="15" name="TextBox 14"/>
-          <p:cNvSpPr txBox="1"/>
-          <p:nvPr/>
-        </p:nvSpPr>
-        <p:spPr>
-          <a:xfrm>
-            <a:off x="1691640" y="2798064"/>
-            <a:ext cx="2560320" cy="411480"/>
-          </a:xfrm>
-          <a:prstGeom prst="rect">
-            <a:avLst/>
-          </a:prstGeom>
-          <a:noFill/>
-        </p:spPr>
-        <p:txBody>
-          <a:bodyPr wrap="square" lIns="0" rIns="0" tIns="0" bIns="0">
-            <a:spAutoFit/>
-          </a:bodyPr>
-          <a:lstStyle/>
-          <a:p>
-            <a:pPr>
-              <a:spcAft>
-                <a:spcPts val="800"/>
-              </a:spcAft>
-              <a:defRPr sz="2300" b="1">
-                <a:solidFill>
                   <a:srgbClr val="173E3C"/>
                 </a:solidFill>
                 <a:latin typeface="Noto Sans CJK JP"/>
@@ -7448,45 +7553,6 @@
             </a:pPr>
             <a:r>
               <a:t>マヌカ</a:t>
-            </a:r>
-          </a:p>
-        </p:txBody>
-      </p:sp>
-      <p:sp>
-        <p:nvSpPr>
-          <p:cNvPr id="16" name="TextBox 15"/>
-          <p:cNvSpPr txBox="1"/>
-          <p:nvPr/>
-        </p:nvSpPr>
-        <p:spPr>
-          <a:xfrm>
-            <a:off x="4352544" y="2871216"/>
-            <a:ext cx="1463040" cy="310896"/>
-          </a:xfrm>
-          <a:prstGeom prst="rect">
-            <a:avLst/>
-          </a:prstGeom>
-          <a:noFill/>
-        </p:spPr>
-        <p:txBody>
-          <a:bodyPr wrap="square" lIns="0" rIns="0" tIns="0" bIns="0">
-            <a:spAutoFit/>
-          </a:bodyPr>
-          <a:lstStyle/>
-          <a:p>
-            <a:pPr>
-              <a:spcAft>
-                <a:spcPts val="800"/>
-              </a:spcAft>
-              <a:defRPr sz="1400" b="0">
-                <a:solidFill>
-                  <a:srgbClr val="61716B"/>
-                </a:solidFill>
-                <a:latin typeface="Noto Sans CJK JP"/>
-              </a:defRPr>
-            </a:pPr>
-            <a:r>
-              <a:t>Manuka</a:t>
             </a:r>
           </a:p>
         </p:txBody>
@@ -7499,8 +7565,8 @@
         </p:nvSpPr>
         <p:spPr>
           <a:xfrm>
-            <a:off x="658368" y="3474720"/>
-            <a:ext cx="5532120" cy="658368"/>
+            <a:off x="6327648" y="1984248"/>
+            <a:ext cx="2596896" cy="1920240"/>
           </a:xfrm>
           <a:prstGeom prst="roundRect">
             <a:avLst>
@@ -7536,73 +7602,60 @@
           </a:p>
         </p:txBody>
       </p:sp>
-      <p:sp>
-        <p:nvSpPr>
-          <p:cNvPr id="18" name="TextBox 17"/>
-          <p:cNvSpPr txBox="1"/>
-          <p:nvPr/>
-        </p:nvSpPr>
-        <p:spPr>
-          <a:xfrm>
-            <a:off x="896112" y="3621024"/>
-            <a:ext cx="521207" cy="320040"/>
-          </a:xfrm>
-          <a:prstGeom prst="rect">
-            <a:avLst/>
-          </a:prstGeom>
-          <a:noFill/>
-        </p:spPr>
-        <p:txBody>
-          <a:bodyPr wrap="square" lIns="0" rIns="0" tIns="0" bIns="0">
-            <a:spAutoFit/>
-          </a:bodyPr>
-          <a:lstStyle/>
-          <a:p>
-            <a:pPr>
+      <p:pic>
+        <p:nvPicPr>
+          <p:cNvPr id="18" name="Picture 17" descr="moe.jpg">
+            <a:hlinkClick r:id="rId7"/>
+          </p:cNvPr>
+          <p:cNvPicPr>
+            <a:picLocks noChangeAspect="1"/>
+          </p:cNvPicPr>
+          <p:nvPr/>
+        </p:nvPicPr>
+        <p:blipFill>
+          <a:blip r:embed="rId6"/>
+          <a:stretch>
+            <a:fillRect/>
+          </a:stretch>
+        </p:blipFill>
+        <p:spPr>
+          <a:xfrm>
+            <a:off x="6894576" y="2075688"/>
+            <a:ext cx="1463040" cy="1463040"/>
+          </a:xfrm>
+          <a:prstGeom prst="rect">
+            <a:avLst/>
+          </a:prstGeom>
+        </p:spPr>
+      </p:pic>
+      <p:sp>
+        <p:nvSpPr>
+          <p:cNvPr id="19" name="TextBox 18"/>
+          <p:cNvSpPr txBox="1"/>
+          <p:nvPr/>
+        </p:nvSpPr>
+        <p:spPr>
+          <a:xfrm>
+            <a:off x="6483096" y="3602736"/>
+            <a:ext cx="2286000" cy="274320"/>
+          </a:xfrm>
+          <a:prstGeom prst="rect">
+            <a:avLst/>
+          </a:prstGeom>
+          <a:noFill/>
+        </p:spPr>
+        <p:txBody>
+          <a:bodyPr wrap="square" lIns="0" rIns="0" tIns="0" bIns="0">
+            <a:spAutoFit/>
+          </a:bodyPr>
+          <a:lstStyle/>
+          <a:p>
+            <a:pPr algn="ctr">
               <a:spcAft>
                 <a:spcPts val="800"/>
               </a:spcAft>
               <a:defRPr sz="1600" b="1">
                 <a:solidFill>
-                  <a:srgbClr val="24685E"/>
-                </a:solidFill>
-                <a:latin typeface="Noto Sans CJK JP"/>
-              </a:defRPr>
-            </a:pPr>
-            <a:r>
-              <a:t>03</a:t>
-            </a:r>
-          </a:p>
-        </p:txBody>
-      </p:sp>
-      <p:sp>
-        <p:nvSpPr>
-          <p:cNvPr id="19" name="TextBox 18"/>
-          <p:cNvSpPr txBox="1"/>
-          <p:nvPr/>
-        </p:nvSpPr>
-        <p:spPr>
-          <a:xfrm>
-            <a:off x="1691640" y="3584448"/>
-            <a:ext cx="2560320" cy="411480"/>
-          </a:xfrm>
-          <a:prstGeom prst="rect">
-            <a:avLst/>
-          </a:prstGeom>
-          <a:noFill/>
-        </p:spPr>
-        <p:txBody>
-          <a:bodyPr wrap="square" lIns="0" rIns="0" tIns="0" bIns="0">
-            <a:spAutoFit/>
-          </a:bodyPr>
-          <a:lstStyle/>
-          <a:p>
-            <a:pPr>
-              <a:spcAft>
-                <a:spcPts val="800"/>
-              </a:spcAft>
-              <a:defRPr sz="2300" b="1">
-                <a:solidFill>
                   <a:srgbClr val="173E3C"/>
                 </a:solidFill>
                 <a:latin typeface="Noto Sans CJK JP"/>
@@ -7616,53 +7669,14 @@
       </p:sp>
       <p:sp>
         <p:nvSpPr>
-          <p:cNvPr id="20" name="TextBox 19"/>
-          <p:cNvSpPr txBox="1"/>
-          <p:nvPr/>
-        </p:nvSpPr>
-        <p:spPr>
-          <a:xfrm>
-            <a:off x="4352544" y="3657600"/>
-            <a:ext cx="1463040" cy="310896"/>
-          </a:xfrm>
-          <a:prstGeom prst="rect">
-            <a:avLst/>
-          </a:prstGeom>
-          <a:noFill/>
-        </p:spPr>
-        <p:txBody>
-          <a:bodyPr wrap="square" lIns="0" rIns="0" tIns="0" bIns="0">
-            <a:spAutoFit/>
-          </a:bodyPr>
-          <a:lstStyle/>
-          <a:p>
-            <a:pPr>
-              <a:spcAft>
-                <a:spcPts val="800"/>
-              </a:spcAft>
-              <a:defRPr sz="1400" b="0">
-                <a:solidFill>
-                  <a:srgbClr val="61716B"/>
-                </a:solidFill>
-                <a:latin typeface="Noto Sans CJK JP"/>
-              </a:defRPr>
-            </a:pPr>
-            <a:r>
-              <a:t>Moe</a:t>
-            </a:r>
-          </a:p>
-        </p:txBody>
-      </p:sp>
-      <p:sp>
-        <p:nvSpPr>
-          <p:cNvPr id="21" name="Rounded Rectangle 20"/>
+          <p:cNvPr id="20" name="Rounded Rectangle 19"/>
           <p:cNvSpPr/>
           <p:nvPr/>
         </p:nvSpPr>
         <p:spPr>
           <a:xfrm>
-            <a:off x="658368" y="4261104"/>
-            <a:ext cx="5532120" cy="658368"/>
+            <a:off x="9162288" y="1984248"/>
+            <a:ext cx="2596896" cy="1920240"/>
           </a:xfrm>
           <a:prstGeom prst="roundRect">
             <a:avLst>
@@ -7698,6 +7712,32 @@
           </a:p>
         </p:txBody>
       </p:sp>
+      <p:pic>
+        <p:nvPicPr>
+          <p:cNvPr id="21" name="Picture 20" descr="lime.jpg">
+            <a:hlinkClick r:id="rId9"/>
+          </p:cNvPr>
+          <p:cNvPicPr>
+            <a:picLocks noChangeAspect="1"/>
+          </p:cNvPicPr>
+          <p:nvPr/>
+        </p:nvPicPr>
+        <p:blipFill>
+          <a:blip r:embed="rId8"/>
+          <a:stretch>
+            <a:fillRect/>
+          </a:stretch>
+        </p:blipFill>
+        <p:spPr>
+          <a:xfrm>
+            <a:off x="9729216" y="2075688"/>
+            <a:ext cx="1463040" cy="1463040"/>
+          </a:xfrm>
+          <a:prstGeom prst="rect">
+            <a:avLst/>
+          </a:prstGeom>
+        </p:spPr>
+      </p:pic>
       <p:sp>
         <p:nvSpPr>
           <p:cNvPr id="22" name="TextBox 21"/>
@@ -7706,65 +7746,26 @@
         </p:nvSpPr>
         <p:spPr>
           <a:xfrm>
-            <a:off x="896112" y="4407408"/>
-            <a:ext cx="521207" cy="320040"/>
-          </a:xfrm>
-          <a:prstGeom prst="rect">
-            <a:avLst/>
-          </a:prstGeom>
-          <a:noFill/>
-        </p:spPr>
-        <p:txBody>
-          <a:bodyPr wrap="square" lIns="0" rIns="0" tIns="0" bIns="0">
-            <a:spAutoFit/>
-          </a:bodyPr>
-          <a:lstStyle/>
-          <a:p>
-            <a:pPr>
+            <a:off x="9317736" y="3602736"/>
+            <a:ext cx="2286000" cy="274320"/>
+          </a:xfrm>
+          <a:prstGeom prst="rect">
+            <a:avLst/>
+          </a:prstGeom>
+          <a:noFill/>
+        </p:spPr>
+        <p:txBody>
+          <a:bodyPr wrap="square" lIns="0" rIns="0" tIns="0" bIns="0">
+            <a:spAutoFit/>
+          </a:bodyPr>
+          <a:lstStyle/>
+          <a:p>
+            <a:pPr algn="ctr">
               <a:spcAft>
                 <a:spcPts val="800"/>
               </a:spcAft>
               <a:defRPr sz="1600" b="1">
                 <a:solidFill>
-                  <a:srgbClr val="24685E"/>
-                </a:solidFill>
-                <a:latin typeface="Noto Sans CJK JP"/>
-              </a:defRPr>
-            </a:pPr>
-            <a:r>
-              <a:t>04</a:t>
-            </a:r>
-          </a:p>
-        </p:txBody>
-      </p:sp>
-      <p:sp>
-        <p:nvSpPr>
-          <p:cNvPr id="23" name="TextBox 22"/>
-          <p:cNvSpPr txBox="1"/>
-          <p:nvPr/>
-        </p:nvSpPr>
-        <p:spPr>
-          <a:xfrm>
-            <a:off x="1691640" y="4370832"/>
-            <a:ext cx="2560320" cy="411480"/>
-          </a:xfrm>
-          <a:prstGeom prst="rect">
-            <a:avLst/>
-          </a:prstGeom>
-          <a:noFill/>
-        </p:spPr>
-        <p:txBody>
-          <a:bodyPr wrap="square" lIns="0" rIns="0" tIns="0" bIns="0">
-            <a:spAutoFit/>
-          </a:bodyPr>
-          <a:lstStyle/>
-          <a:p>
-            <a:pPr>
-              <a:spcAft>
-                <a:spcPts val="800"/>
-              </a:spcAft>
-              <a:defRPr sz="2300" b="1">
-                <a:solidFill>
                   <a:srgbClr val="173E3C"/>
                 </a:solidFill>
                 <a:latin typeface="Noto Sans CJK JP"/>
@@ -7778,53 +7779,14 @@
       </p:sp>
       <p:sp>
         <p:nvSpPr>
-          <p:cNvPr id="24" name="TextBox 23"/>
-          <p:cNvSpPr txBox="1"/>
-          <p:nvPr/>
-        </p:nvSpPr>
-        <p:spPr>
-          <a:xfrm>
-            <a:off x="4352544" y="4443984"/>
-            <a:ext cx="1463040" cy="310896"/>
-          </a:xfrm>
-          <a:prstGeom prst="rect">
-            <a:avLst/>
-          </a:prstGeom>
-          <a:noFill/>
-        </p:spPr>
-        <p:txBody>
-          <a:bodyPr wrap="square" lIns="0" rIns="0" tIns="0" bIns="0">
-            <a:spAutoFit/>
-          </a:bodyPr>
-          <a:lstStyle/>
-          <a:p>
-            <a:pPr>
-              <a:spcAft>
-                <a:spcPts val="800"/>
-              </a:spcAft>
-              <a:defRPr sz="1400" b="0">
-                <a:solidFill>
-                  <a:srgbClr val="61716B"/>
-                </a:solidFill>
-                <a:latin typeface="Noto Sans CJK JP"/>
-              </a:defRPr>
-            </a:pPr>
-            <a:r>
-              <a:t>Lime</a:t>
-            </a:r>
-          </a:p>
-        </p:txBody>
-      </p:sp>
-      <p:sp>
-        <p:nvSpPr>
-          <p:cNvPr id="25" name="Rounded Rectangle 24"/>
+          <p:cNvPr id="23" name="Rounded Rectangle 22"/>
           <p:cNvSpPr/>
           <p:nvPr/>
         </p:nvSpPr>
         <p:spPr>
           <a:xfrm>
-            <a:off x="658368" y="5047488"/>
-            <a:ext cx="5532120" cy="658368"/>
+            <a:off x="2075688" y="4361688"/>
+            <a:ext cx="2596896" cy="1920240"/>
           </a:xfrm>
           <a:prstGeom prst="roundRect">
             <a:avLst>
@@ -7860,142 +7822,26 @@
           </a:p>
         </p:txBody>
       </p:sp>
-      <p:sp>
-        <p:nvSpPr>
-          <p:cNvPr id="26" name="TextBox 25"/>
-          <p:cNvSpPr txBox="1"/>
-          <p:nvPr/>
-        </p:nvSpPr>
-        <p:spPr>
-          <a:xfrm>
-            <a:off x="896112" y="5193792"/>
-            <a:ext cx="521207" cy="320040"/>
-          </a:xfrm>
-          <a:prstGeom prst="rect">
-            <a:avLst/>
-          </a:prstGeom>
-          <a:noFill/>
-        </p:spPr>
-        <p:txBody>
-          <a:bodyPr wrap="square" lIns="0" rIns="0" tIns="0" bIns="0">
-            <a:spAutoFit/>
-          </a:bodyPr>
-          <a:lstStyle/>
-          <a:p>
-            <a:pPr>
-              <a:spcAft>
-                <a:spcPts val="800"/>
-              </a:spcAft>
-              <a:defRPr sz="1600" b="1">
-                <a:solidFill>
-                  <a:srgbClr val="24685E"/>
-                </a:solidFill>
-                <a:latin typeface="Noto Sans CJK JP"/>
-              </a:defRPr>
-            </a:pPr>
-            <a:r>
-              <a:t>05</a:t>
-            </a:r>
-          </a:p>
-        </p:txBody>
-      </p:sp>
-      <p:sp>
-        <p:nvSpPr>
-          <p:cNvPr id="27" name="TextBox 26"/>
-          <p:cNvSpPr txBox="1"/>
-          <p:nvPr/>
-        </p:nvSpPr>
-        <p:spPr>
-          <a:xfrm>
-            <a:off x="1691640" y="5157216"/>
-            <a:ext cx="2560320" cy="411480"/>
-          </a:xfrm>
-          <a:prstGeom prst="rect">
-            <a:avLst/>
-          </a:prstGeom>
-          <a:noFill/>
-        </p:spPr>
-        <p:txBody>
-          <a:bodyPr wrap="square" lIns="0" rIns="0" tIns="0" bIns="0">
-            <a:spAutoFit/>
-          </a:bodyPr>
-          <a:lstStyle/>
-          <a:p>
-            <a:pPr>
-              <a:spcAft>
-                <a:spcPts val="800"/>
-              </a:spcAft>
-              <a:defRPr sz="2300" b="1">
-                <a:solidFill>
-                  <a:srgbClr val="173E3C"/>
-                </a:solidFill>
-                <a:latin typeface="Noto Sans CJK JP"/>
-              </a:defRPr>
-            </a:pPr>
-            <a:r>
-              <a:t>桔梗</a:t>
-            </a:r>
-          </a:p>
-        </p:txBody>
-      </p:sp>
-      <p:sp>
-        <p:nvSpPr>
-          <p:cNvPr id="28" name="TextBox 27"/>
-          <p:cNvSpPr txBox="1"/>
-          <p:nvPr/>
-        </p:nvSpPr>
-        <p:spPr>
-          <a:xfrm>
-            <a:off x="4352544" y="5230368"/>
-            <a:ext cx="1463040" cy="310896"/>
-          </a:xfrm>
-          <a:prstGeom prst="rect">
-            <a:avLst/>
-          </a:prstGeom>
-          <a:noFill/>
-        </p:spPr>
-        <p:txBody>
-          <a:bodyPr wrap="square" lIns="0" rIns="0" tIns="0" bIns="0">
-            <a:spAutoFit/>
-          </a:bodyPr>
-          <a:lstStyle/>
-          <a:p>
-            <a:pPr>
-              <a:spcAft>
-                <a:spcPts val="800"/>
-              </a:spcAft>
-              <a:defRPr sz="1400" b="0">
-                <a:solidFill>
-                  <a:srgbClr val="61716B"/>
-                </a:solidFill>
-                <a:latin typeface="Noto Sans CJK JP"/>
-              </a:defRPr>
-            </a:pPr>
-            <a:r>
-              <a:t>Kikyo</a:t>
-            </a:r>
-          </a:p>
-        </p:txBody>
-      </p:sp>
       <p:pic>
         <p:nvPicPr>
-          <p:cNvPr id="29" name="Picture 28" descr="exec-871844d4-edbb-4a08-9d69-90132a8b8d7d.png"/>
+          <p:cNvPr id="24" name="Picture 23" descr="komano.jpg">
+            <a:hlinkClick r:id="rId11"/>
+          </p:cNvPr>
           <p:cNvPicPr>
             <a:picLocks noChangeAspect="1"/>
           </p:cNvPicPr>
           <p:nvPr/>
         </p:nvPicPr>
         <p:blipFill>
-          <a:blip r:embed="rId2"/>
-          <a:srcRect l="50000" t="50000"/>
+          <a:blip r:embed="rId10"/>
           <a:stretch>
             <a:fillRect/>
           </a:stretch>
         </p:blipFill>
         <p:spPr>
           <a:xfrm>
-            <a:off x="7114032" y="1929384"/>
-            <a:ext cx="4096512" cy="4096512"/>
+            <a:off x="2642616" y="4453127"/>
+            <a:ext cx="1463040" cy="1463040"/>
           </a:xfrm>
           <a:prstGeom prst="rect">
             <a:avLst/>
@@ -8004,31 +7850,290 @@
       </p:pic>
       <p:sp>
         <p:nvSpPr>
-          <p:cNvPr id="30" name="TextBox 29"/>
-          <p:cNvSpPr txBox="1"/>
-          <p:nvPr/>
-        </p:nvSpPr>
-        <p:spPr>
-          <a:xfrm>
-            <a:off x="7114032" y="6099048"/>
-            <a:ext cx="4096512" cy="274320"/>
-          </a:xfrm>
-          <a:prstGeom prst="rect">
-            <a:avLst/>
-          </a:prstGeom>
-          <a:noFill/>
-        </p:spPr>
-        <p:txBody>
-          <a:bodyPr wrap="square" lIns="0" rIns="0" tIns="0" bIns="0">
-            <a:spAutoFit/>
-          </a:bodyPr>
-          <a:lstStyle/>
-          <a:p>
-            <a:pPr>
-              <a:spcAft>
-                <a:spcPts val="800"/>
-              </a:spcAft>
-              <a:defRPr sz="800" b="0">
+          <p:cNvPr id="25" name="TextBox 24"/>
+          <p:cNvSpPr txBox="1"/>
+          <p:nvPr/>
+        </p:nvSpPr>
+        <p:spPr>
+          <a:xfrm>
+            <a:off x="2231136" y="5980175"/>
+            <a:ext cx="2286000" cy="274320"/>
+          </a:xfrm>
+          <a:prstGeom prst="rect">
+            <a:avLst/>
+          </a:prstGeom>
+          <a:noFill/>
+        </p:spPr>
+        <p:txBody>
+          <a:bodyPr wrap="square" lIns="0" rIns="0" tIns="0" bIns="0">
+            <a:spAutoFit/>
+          </a:bodyPr>
+          <a:lstStyle/>
+          <a:p>
+            <a:pPr algn="ctr">
+              <a:spcAft>
+                <a:spcPts val="800"/>
+              </a:spcAft>
+              <a:defRPr sz="1600" b="1">
+                <a:solidFill>
+                  <a:srgbClr val="173E3C"/>
+                </a:solidFill>
+                <a:latin typeface="Noto Sans CJK JP"/>
+              </a:defRPr>
+            </a:pPr>
+            <a:r>
+              <a:t>狛乃</a:t>
+            </a:r>
+          </a:p>
+        </p:txBody>
+      </p:sp>
+      <p:sp>
+        <p:nvSpPr>
+          <p:cNvPr id="26" name="Rounded Rectangle 25"/>
+          <p:cNvSpPr/>
+          <p:nvPr/>
+        </p:nvSpPr>
+        <p:spPr>
+          <a:xfrm>
+            <a:off x="4910328" y="4361688"/>
+            <a:ext cx="2596896" cy="1920240"/>
+          </a:xfrm>
+          <a:prstGeom prst="roundRect">
+            <a:avLst>
+              <a:gd name="adj" fmla="val 10000"/>
+            </a:avLst>
+          </a:prstGeom>
+          <a:solidFill>
+            <a:srgbClr val="FFFFFF"/>
+          </a:solidFill>
+          <a:ln>
+            <a:noFill/>
+          </a:ln>
+        </p:spPr>
+        <p:style>
+          <a:lnRef idx="1">
+            <a:schemeClr val="accent1"/>
+          </a:lnRef>
+          <a:fillRef idx="3">
+            <a:schemeClr val="accent1"/>
+          </a:fillRef>
+          <a:effectRef idx="2">
+            <a:schemeClr val="accent1"/>
+          </a:effectRef>
+          <a:fontRef idx="minor">
+            <a:schemeClr val="lt1"/>
+          </a:fontRef>
+        </p:style>
+        <p:txBody>
+          <a:bodyPr rtlCol="0" anchor="ctr"/>
+          <a:lstStyle/>
+          <a:p>
+            <a:pPr algn="ctr"/>
+          </a:p>
+        </p:txBody>
+      </p:sp>
+      <p:pic>
+        <p:nvPicPr>
+          <p:cNvPr id="27" name="Picture 26" descr="maki.jpg">
+            <a:hlinkClick r:id="rId13"/>
+          </p:cNvPr>
+          <p:cNvPicPr>
+            <a:picLocks noChangeAspect="1"/>
+          </p:cNvPicPr>
+          <p:nvPr/>
+        </p:nvPicPr>
+        <p:blipFill>
+          <a:blip r:embed="rId12"/>
+          <a:stretch>
+            <a:fillRect/>
+          </a:stretch>
+        </p:blipFill>
+        <p:spPr>
+          <a:xfrm>
+            <a:off x="5477256" y="4453127"/>
+            <a:ext cx="1463040" cy="1463040"/>
+          </a:xfrm>
+          <a:prstGeom prst="rect">
+            <a:avLst/>
+          </a:prstGeom>
+        </p:spPr>
+      </p:pic>
+      <p:sp>
+        <p:nvSpPr>
+          <p:cNvPr id="28" name="TextBox 27"/>
+          <p:cNvSpPr txBox="1"/>
+          <p:nvPr/>
+        </p:nvSpPr>
+        <p:spPr>
+          <a:xfrm>
+            <a:off x="5065776" y="5980175"/>
+            <a:ext cx="2286000" cy="274320"/>
+          </a:xfrm>
+          <a:prstGeom prst="rect">
+            <a:avLst/>
+          </a:prstGeom>
+          <a:noFill/>
+        </p:spPr>
+        <p:txBody>
+          <a:bodyPr wrap="square" lIns="0" rIns="0" tIns="0" bIns="0">
+            <a:spAutoFit/>
+          </a:bodyPr>
+          <a:lstStyle/>
+          <a:p>
+            <a:pPr algn="ctr">
+              <a:spcAft>
+                <a:spcPts val="800"/>
+              </a:spcAft>
+              <a:defRPr sz="1600" b="1">
+                <a:solidFill>
+                  <a:srgbClr val="173E3C"/>
+                </a:solidFill>
+                <a:latin typeface="Noto Sans CJK JP"/>
+              </a:defRPr>
+            </a:pPr>
+            <a:r>
+              <a:t>碼希</a:t>
+            </a:r>
+          </a:p>
+        </p:txBody>
+      </p:sp>
+      <p:sp>
+        <p:nvSpPr>
+          <p:cNvPr id="29" name="Rounded Rectangle 28"/>
+          <p:cNvSpPr/>
+          <p:nvPr/>
+        </p:nvSpPr>
+        <p:spPr>
+          <a:xfrm>
+            <a:off x="7744968" y="4361688"/>
+            <a:ext cx="2596896" cy="1920240"/>
+          </a:xfrm>
+          <a:prstGeom prst="roundRect">
+            <a:avLst>
+              <a:gd name="adj" fmla="val 10000"/>
+            </a:avLst>
+          </a:prstGeom>
+          <a:solidFill>
+            <a:srgbClr val="FFFFFF"/>
+          </a:solidFill>
+          <a:ln>
+            <a:noFill/>
+          </a:ln>
+        </p:spPr>
+        <p:style>
+          <a:lnRef idx="1">
+            <a:schemeClr val="accent1"/>
+          </a:lnRef>
+          <a:fillRef idx="3">
+            <a:schemeClr val="accent1"/>
+          </a:fillRef>
+          <a:effectRef idx="2">
+            <a:schemeClr val="accent1"/>
+          </a:effectRef>
+          <a:fontRef idx="minor">
+            <a:schemeClr val="lt1"/>
+          </a:fontRef>
+        </p:style>
+        <p:txBody>
+          <a:bodyPr rtlCol="0" anchor="ctr"/>
+          <a:lstStyle/>
+          <a:p>
+            <a:pPr algn="ctr"/>
+          </a:p>
+        </p:txBody>
+      </p:sp>
+      <p:pic>
+        <p:nvPicPr>
+          <p:cNvPr id="30" name="Picture 29" descr="kuuta.jpg">
+            <a:hlinkClick r:id="rId15"/>
+          </p:cNvPr>
+          <p:cNvPicPr>
+            <a:picLocks noChangeAspect="1"/>
+          </p:cNvPicPr>
+          <p:nvPr/>
+        </p:nvPicPr>
+        <p:blipFill>
+          <a:blip r:embed="rId14"/>
+          <a:stretch>
+            <a:fillRect/>
+          </a:stretch>
+        </p:blipFill>
+        <p:spPr>
+          <a:xfrm>
+            <a:off x="8311896" y="4453127"/>
+            <a:ext cx="1463040" cy="1463040"/>
+          </a:xfrm>
+          <a:prstGeom prst="rect">
+            <a:avLst/>
+          </a:prstGeom>
+        </p:spPr>
+      </p:pic>
+      <p:sp>
+        <p:nvSpPr>
+          <p:cNvPr id="31" name="TextBox 30"/>
+          <p:cNvSpPr txBox="1"/>
+          <p:nvPr/>
+        </p:nvSpPr>
+        <p:spPr>
+          <a:xfrm>
+            <a:off x="7900416" y="5980175"/>
+            <a:ext cx="2286000" cy="274320"/>
+          </a:xfrm>
+          <a:prstGeom prst="rect">
+            <a:avLst/>
+          </a:prstGeom>
+          <a:noFill/>
+        </p:spPr>
+        <p:txBody>
+          <a:bodyPr wrap="square" lIns="0" rIns="0" tIns="0" bIns="0">
+            <a:spAutoFit/>
+          </a:bodyPr>
+          <a:lstStyle/>
+          <a:p>
+            <a:pPr algn="ctr">
+              <a:spcAft>
+                <a:spcPts val="800"/>
+              </a:spcAft>
+              <a:defRPr sz="1600" b="1">
+                <a:solidFill>
+                  <a:srgbClr val="173E3C"/>
+                </a:solidFill>
+                <a:latin typeface="Noto Sans CJK JP"/>
+              </a:defRPr>
+            </a:pPr>
+            <a:r>
+              <a:t>くうた</a:t>
+            </a:r>
+          </a:p>
+        </p:txBody>
+      </p:sp>
+      <p:sp>
+        <p:nvSpPr>
+          <p:cNvPr id="32" name="TextBox 31"/>
+          <p:cNvSpPr txBox="1"/>
+          <p:nvPr/>
+        </p:nvSpPr>
+        <p:spPr>
+          <a:xfrm>
+            <a:off x="8183879" y="6291072"/>
+            <a:ext cx="3200400" cy="128016"/>
+          </a:xfrm>
+          <a:prstGeom prst="rect">
+            <a:avLst/>
+          </a:prstGeom>
+          <a:noFill/>
+        </p:spPr>
+        <p:txBody>
+          <a:bodyPr wrap="square" lIns="0" rIns="0" tIns="0" bIns="0">
+            <a:spAutoFit/>
+          </a:bodyPr>
+          <a:lstStyle/>
+          <a:p>
+            <a:pPr>
+              <a:spcAft>
+                <a:spcPts val="800"/>
+              </a:spcAft>
+              <a:defRPr sz="700" b="0">
                 <a:solidFill>
                   <a:srgbClr val="61716B"/>
                 </a:solidFill>
@@ -8036,7 +8141,7 @@
               </a:defRPr>
             </a:pPr>
             <a:r>
-              <a:t>参考イメージ（AI生成）</a:t>
+              <a:t>画像出典：各モデルのBOOTH販売ページ</a:t>
             </a:r>
           </a:p>
         </p:txBody>
@@ -8304,7 +8409,7 @@
               </a:defRPr>
             </a:pPr>
             <a:r>
-              <a:t>アース製薬 企業ブース｜3Dお風呂セット 制作発注資料｜制作内容 v0.4</a:t>
+              <a:t>アース製薬 企業ブース｜3Dお風呂セット 制作発注資料｜制作内容 v0.5</a:t>
             </a:r>
           </a:p>
         </p:txBody>
@@ -8967,7 +9072,7 @@
               </a:defRPr>
             </a:pPr>
             <a:r>
-              <a:t>アース製薬 企業ブース｜3Dお風呂セット 制作発注資料｜制作内容 v0.4</a:t>
+              <a:t>アース製薬 企業ブース｜3Dお風呂セット 制作発注資料｜制作内容 v0.5</a:t>
             </a:r>
           </a:p>
         </p:txBody>
@@ -9013,7 +9118,7 @@
       </p:sp>
       <p:pic>
         <p:nvPicPr>
-          <p:cNvPr id="9" name="Picture 8" descr="exec-871844d4-edbb-4a08-9d69-90132a8b8d7d.png"/>
+          <p:cNvPr id="9" name="Picture 8" descr="exec-c7a9a72c-5423-4325-bae1-c7d3b8f836c6.png"/>
           <p:cNvPicPr>
             <a:picLocks noChangeAspect="1"/>
           </p:cNvPicPr>
@@ -9021,6 +9126,7 @@
         </p:nvPicPr>
         <p:blipFill>
           <a:blip r:embed="rId2"/>
+          <a:srcRect r="50000" b="50000"/>
           <a:stretch>
             <a:fillRect/>
           </a:stretch>
@@ -9028,16 +9134,91 @@
         <p:spPr>
           <a:xfrm>
             <a:off x="640080" y="1920240"/>
-            <a:ext cx="4069080" cy="4069080"/>
+            <a:ext cx="2034540" cy="2034540"/>
           </a:xfrm>
           <a:prstGeom prst="rect">
             <a:avLst/>
           </a:prstGeom>
         </p:spPr>
       </p:pic>
-      <p:sp>
-        <p:nvSpPr>
-          <p:cNvPr id="10" name="TextBox 9"/>
+      <p:pic>
+        <p:nvPicPr>
+          <p:cNvPr id="10" name="Picture 9" descr="exec-c7a9a72c-5423-4325-bae1-c7d3b8f836c6.png"/>
+          <p:cNvPicPr>
+            <a:picLocks noChangeAspect="1"/>
+          </p:cNvPicPr>
+          <p:nvPr/>
+        </p:nvPicPr>
+        <p:blipFill>
+          <a:blip r:embed="rId2"/>
+          <a:srcRect l="50000" b="50000"/>
+          <a:stretch>
+            <a:fillRect/>
+          </a:stretch>
+        </p:blipFill>
+        <p:spPr>
+          <a:xfrm>
+            <a:off x="2674620" y="1920240"/>
+            <a:ext cx="2034540" cy="2034540"/>
+          </a:xfrm>
+          <a:prstGeom prst="rect">
+            <a:avLst/>
+          </a:prstGeom>
+        </p:spPr>
+      </p:pic>
+      <p:pic>
+        <p:nvPicPr>
+          <p:cNvPr id="11" name="Picture 10" descr="exec-871844d4-edbb-4a08-9d69-90132a8b8d7d.png"/>
+          <p:cNvPicPr>
+            <a:picLocks noChangeAspect="1"/>
+          </p:cNvPicPr>
+          <p:nvPr/>
+        </p:nvPicPr>
+        <p:blipFill>
+          <a:blip r:embed="rId3"/>
+          <a:srcRect r="50000" t="50000"/>
+          <a:stretch>
+            <a:fillRect/>
+          </a:stretch>
+        </p:blipFill>
+        <p:spPr>
+          <a:xfrm>
+            <a:off x="640080" y="3954780"/>
+            <a:ext cx="2034540" cy="2034540"/>
+          </a:xfrm>
+          <a:prstGeom prst="rect">
+            <a:avLst/>
+          </a:prstGeom>
+        </p:spPr>
+      </p:pic>
+      <p:pic>
+        <p:nvPicPr>
+          <p:cNvPr id="12" name="Picture 11" descr="exec-871844d4-edbb-4a08-9d69-90132a8b8d7d.png"/>
+          <p:cNvPicPr>
+            <a:picLocks noChangeAspect="1"/>
+          </p:cNvPicPr>
+          <p:nvPr/>
+        </p:nvPicPr>
+        <p:blipFill>
+          <a:blip r:embed="rId3"/>
+          <a:srcRect l="50000" t="50000"/>
+          <a:stretch>
+            <a:fillRect/>
+          </a:stretch>
+        </p:blipFill>
+        <p:spPr>
+          <a:xfrm>
+            <a:off x="2674620" y="3954780"/>
+            <a:ext cx="2034540" cy="2034540"/>
+          </a:xfrm>
+          <a:prstGeom prst="rect">
+            <a:avLst/>
+          </a:prstGeom>
+        </p:spPr>
+      </p:pic>
+      <p:sp>
+        <p:nvSpPr>
+          <p:cNvPr id="13" name="TextBox 12"/>
           <p:cNvSpPr txBox="1"/>
           <p:nvPr/>
         </p:nvSpPr>
@@ -9076,7 +9257,7 @@
       </p:sp>
       <p:sp>
         <p:nvSpPr>
-          <p:cNvPr id="11" name="Rounded Rectangle 10"/>
+          <p:cNvPr id="14" name="Rounded Rectangle 13"/>
           <p:cNvSpPr/>
           <p:nvPr/>
         </p:nvSpPr>
@@ -9121,7 +9302,7 @@
       </p:sp>
       <p:sp>
         <p:nvSpPr>
-          <p:cNvPr id="12" name="TextBox 11"/>
+          <p:cNvPr id="15" name="TextBox 14"/>
           <p:cNvSpPr txBox="1"/>
           <p:nvPr/>
         </p:nvSpPr>
@@ -9160,7 +9341,7 @@
       </p:sp>
       <p:sp>
         <p:nvSpPr>
-          <p:cNvPr id="13" name="TextBox 12"/>
+          <p:cNvPr id="16" name="TextBox 15"/>
           <p:cNvSpPr txBox="1"/>
           <p:nvPr/>
         </p:nvSpPr>
@@ -9199,7 +9380,7 @@
       </p:sp>
       <p:sp>
         <p:nvSpPr>
-          <p:cNvPr id="14" name="TextBox 13"/>
+          <p:cNvPr id="17" name="TextBox 16"/>
           <p:cNvSpPr txBox="1"/>
           <p:nvPr/>
         </p:nvSpPr>
@@ -9238,7 +9419,7 @@
       </p:sp>
       <p:sp>
         <p:nvSpPr>
-          <p:cNvPr id="15" name="Rounded Rectangle 14"/>
+          <p:cNvPr id="18" name="Rounded Rectangle 17"/>
           <p:cNvSpPr/>
           <p:nvPr/>
         </p:nvSpPr>
@@ -9283,7 +9464,7 @@
       </p:sp>
       <p:sp>
         <p:nvSpPr>
-          <p:cNvPr id="16" name="TextBox 15"/>
+          <p:cNvPr id="19" name="TextBox 18"/>
           <p:cNvSpPr txBox="1"/>
           <p:nvPr/>
         </p:nvSpPr>
@@ -9322,7 +9503,7 @@
       </p:sp>
       <p:sp>
         <p:nvSpPr>
-          <p:cNvPr id="17" name="TextBox 16"/>
+          <p:cNvPr id="20" name="TextBox 19"/>
           <p:cNvSpPr txBox="1"/>
           <p:nvPr/>
         </p:nvSpPr>
@@ -9361,7 +9542,7 @@
       </p:sp>
       <p:sp>
         <p:nvSpPr>
-          <p:cNvPr id="18" name="TextBox 17"/>
+          <p:cNvPr id="21" name="TextBox 20"/>
           <p:cNvSpPr txBox="1"/>
           <p:nvPr/>
         </p:nvSpPr>
@@ -9400,7 +9581,7 @@
       </p:sp>
       <p:sp>
         <p:nvSpPr>
-          <p:cNvPr id="19" name="Rounded Rectangle 18"/>
+          <p:cNvPr id="22" name="Rounded Rectangle 21"/>
           <p:cNvSpPr/>
           <p:nvPr/>
         </p:nvSpPr>
@@ -9445,7 +9626,7 @@
       </p:sp>
       <p:sp>
         <p:nvSpPr>
-          <p:cNvPr id="20" name="TextBox 19"/>
+          <p:cNvPr id="23" name="TextBox 22"/>
           <p:cNvSpPr txBox="1"/>
           <p:nvPr/>
         </p:nvSpPr>
@@ -9484,7 +9665,7 @@
       </p:sp>
       <p:sp>
         <p:nvSpPr>
-          <p:cNvPr id="21" name="TextBox 20"/>
+          <p:cNvPr id="24" name="TextBox 23"/>
           <p:cNvSpPr txBox="1"/>
           <p:nvPr/>
         </p:nvSpPr>
@@ -9523,7 +9704,7 @@
       </p:sp>
       <p:sp>
         <p:nvSpPr>
-          <p:cNvPr id="22" name="TextBox 21"/>
+          <p:cNvPr id="25" name="TextBox 24"/>
           <p:cNvSpPr txBox="1"/>
           <p:nvPr/>
         </p:nvSpPr>

</xml_diff>

<commit_message>
Update avatar references to requested female and male lineup
</commit_message>
<xml_diff>
--- a/documents/slides/bath-set-production-slides.pptx
+++ b/documents/slides/bath-set-production-slides.pptx
@@ -3340,7 +3340,7 @@
               </a:defRPr>
             </a:pPr>
             <a:r>
-              <a:t>アース製薬 企業ブース｜3Dお風呂セット 制作発注資料｜制作内容 v0.5</a:t>
+              <a:t>アース製薬 企業ブース｜3Dお風呂セット 制作発注資料｜制作内容 v0.6</a:t>
             </a:r>
           </a:p>
         </p:txBody>
@@ -4148,7 +4148,7 @@
               </a:defRPr>
             </a:pPr>
             <a:r>
-              <a:t>アース製薬 企業ブース｜3Dお風呂セット 制作発注資料｜制作内容 v0.5</a:t>
+              <a:t>アース製薬 企業ブース｜3Dお風呂セット 制作発注資料｜制作内容 v0.6</a:t>
             </a:r>
           </a:p>
         </p:txBody>
@@ -5281,7 +5281,7 @@
               </a:defRPr>
             </a:pPr>
             <a:r>
-              <a:t>アース製薬 企業ブース｜3Dお風呂セット 制作発注資料｜制作内容 v0.5</a:t>
+              <a:t>アース製薬 企業ブース｜3Dお風呂セット 制作発注資料｜制作内容 v0.6</a:t>
             </a:r>
           </a:p>
         </p:txBody>
@@ -6010,7 +6010,7 @@
               </a:defRPr>
             </a:pPr>
             <a:r>
-              <a:t>アース製薬 企業ブース｜3Dお風呂セット 制作発注資料｜制作内容 v0.5</a:t>
+              <a:t>アース製薬 企業ブース｜3Dお風呂セット 制作発注資料｜制作内容 v0.6</a:t>
             </a:r>
           </a:p>
         </p:txBody>
@@ -6559,7 +6559,7 @@
               </a:defRPr>
             </a:pPr>
             <a:r>
-              <a:t>アース製薬 企業ブース｜3Dお風呂セット 制作発注資料｜制作内容 v0.5</a:t>
+              <a:t>アース製薬 企業ブース｜3Dお風呂セット 制作発注資料｜制作内容 v0.6</a:t>
             </a:r>
           </a:p>
         </p:txBody>
@@ -7215,7 +7215,7 @@
               </a:defRPr>
             </a:pPr>
             <a:r>
-              <a:t>アース製薬 企業ブース｜3Dお風呂セット 制作発注資料｜制作内容 v0.5</a:t>
+              <a:t>アース製薬 企業ブース｜3Dお風呂セット 制作発注資料｜制作内容 v0.6</a:t>
             </a:r>
           </a:p>
         </p:txBody>
@@ -7714,7 +7714,7 @@
       </p:sp>
       <p:pic>
         <p:nvPicPr>
-          <p:cNvPr id="21" name="Picture 20" descr="lime.jpg">
+          <p:cNvPr id="21" name="Picture 20" descr="kikyo.jpg">
             <a:hlinkClick r:id="rId9"/>
           </p:cNvPr>
           <p:cNvPicPr>
@@ -7772,7 +7772,7 @@
               </a:defRPr>
             </a:pPr>
             <a:r>
-              <a:t>ライム</a:t>
+              <a:t>桔梗</a:t>
             </a:r>
           </a:p>
         </p:txBody>
@@ -7824,7 +7824,7 @@
       </p:sp>
       <p:pic>
         <p:nvPicPr>
-          <p:cNvPr id="24" name="Picture 23" descr="komano.jpg">
+          <p:cNvPr id="24" name="Picture 23" descr="vlau.jpg">
             <a:hlinkClick r:id="rId11"/>
           </p:cNvPr>
           <p:cNvPicPr>
@@ -7874,7 +7874,7 @@
               <a:spcAft>
                 <a:spcPts val="800"/>
               </a:spcAft>
-              <a:defRPr sz="1600" b="1">
+              <a:defRPr sz="1300" b="1">
                 <a:solidFill>
                   <a:srgbClr val="173E3C"/>
                 </a:solidFill>
@@ -7882,7 +7882,7 @@
               </a:defRPr>
             </a:pPr>
             <a:r>
-              <a:t>狛乃</a:t>
+              <a:t>ドラゴニュート・ヴラウ</a:t>
             </a:r>
           </a:p>
         </p:txBody>
@@ -7934,7 +7934,7 @@
       </p:sp>
       <p:pic>
         <p:nvPicPr>
-          <p:cNvPr id="27" name="Picture 26" descr="maki.jpg">
+          <p:cNvPr id="27" name="Picture 26" descr="bamessa.jpg">
             <a:hlinkClick r:id="rId13"/>
           </p:cNvPr>
           <p:cNvPicPr>
@@ -7992,7 +7992,7 @@
               </a:defRPr>
             </a:pPr>
             <a:r>
-              <a:t>碼希</a:t>
+              <a:t>バメッサ</a:t>
             </a:r>
           </a:p>
         </p:txBody>
@@ -8044,7 +8044,7 @@
       </p:sp>
       <p:pic>
         <p:nvPicPr>
-          <p:cNvPr id="30" name="Picture 29" descr="kuuta.jpg">
+          <p:cNvPr id="30" name="Picture 29" descr="komano.jpg">
             <a:hlinkClick r:id="rId15"/>
           </p:cNvPr>
           <p:cNvPicPr>
@@ -8102,7 +8102,7 @@
               </a:defRPr>
             </a:pPr>
             <a:r>
-              <a:t>くうた</a:t>
+              <a:t>狛乃</a:t>
             </a:r>
           </a:p>
         </p:txBody>
@@ -8409,7 +8409,7 @@
               </a:defRPr>
             </a:pPr>
             <a:r>
-              <a:t>アース製薬 企業ブース｜3Dお風呂セット 制作発注資料｜制作内容 v0.5</a:t>
+              <a:t>アース製薬 企業ブース｜3Dお風呂セット 制作発注資料｜制作内容 v0.6</a:t>
             </a:r>
           </a:p>
         </p:txBody>
@@ -9072,7 +9072,7 @@
               </a:defRPr>
             </a:pPr>
             <a:r>
-              <a:t>アース製薬 企業ブース｜3Dお風呂セット 制作発注資料｜制作内容 v0.5</a:t>
+              <a:t>アース製薬 企業ブース｜3Dお風呂セット 制作発注資料｜制作内容 v0.6</a:t>
             </a:r>
           </a:p>
         </p:txBody>

</xml_diff>